<commit_message>
Update part 3 deck with renumbered series and QA fixes
Rebuilt to 27 slides after the series shrank to 5 parts, plus overlap
fixes on the mechanism-detail and detection-layer slides found in visual QA.

Co-Authored-By: Claude Sonnet 5 <noreply@anthropic.com>
Claude-Session: https://claude.ai/code/session_01DpSN8JwCJ3tg3JVUadr2zE
</commit_message>
<xml_diff>
--- a/docs/presentations/03-zaschita-dannyh-pii-dlp.pptx
+++ b/docs/presentations/03-zaschita-dannyh-pii-dlp.pptx
@@ -22852,11 +22852,11 @@
         <p:spPr>
           <a:xfrm>
             <a:off x="502920" y="1645920"/>
-            <a:ext cx="5486400" cy="1170432"/>
+            <a:ext cx="5486400" cy="2194560"/>
           </a:xfrm>
           <a:prstGeom prst="roundRect">
             <a:avLst>
-              <a:gd name="adj" fmla="val 6250"/>
+              <a:gd name="adj" fmla="val 3333"/>
             </a:avLst>
           </a:prstGeom>
           <a:solidFill>
@@ -22878,8 +22878,8 @@
         </p:nvSpPr>
         <p:spPr>
           <a:xfrm>
-            <a:off x="667512" y="1810512"/>
-            <a:ext cx="457200" cy="457200"/>
+            <a:off x="685800" y="1828800"/>
+            <a:ext cx="438912" cy="438912"/>
           </a:xfrm>
           <a:prstGeom prst="ellipse">
             <a:avLst/>
@@ -22906,8 +22906,8 @@
         </p:blipFill>
         <p:spPr>
           <a:xfrm>
-            <a:off x="781812" y="1924812"/>
-            <a:ext cx="228600" cy="228600"/>
+            <a:off x="795528" y="1938528"/>
+            <a:ext cx="219456" cy="219456"/>
           </a:xfrm>
           <a:prstGeom prst="rect">
             <a:avLst/>
@@ -22922,20 +22922,23 @@
         </p:nvSpPr>
         <p:spPr>
           <a:xfrm>
-            <a:off x="1252728" y="1737360"/>
-            <a:ext cx="4572000" cy="347472"/>
-          </a:xfrm>
-          <a:prstGeom prst="rect">
-            <a:avLst/>
-          </a:prstGeom>
-          <a:noFill/>
-          <a:ln/>
-        </p:spPr>
-        <p:txBody>
-          <a:bodyPr wrap="square" lIns="0" tIns="0" rIns="0" bIns="0" rtlCol="0" anchor="ctr"/>
-          <a:lstStyle/>
-          <a:p>
-            <a:pPr indent="0" marL="0">
+            <a:off x="1252728" y="1792224"/>
+            <a:ext cx="4526280" cy="594360"/>
+          </a:xfrm>
+          <a:prstGeom prst="rect">
+            <a:avLst/>
+          </a:prstGeom>
+          <a:noFill/>
+          <a:ln/>
+        </p:spPr>
+        <p:txBody>
+          <a:bodyPr wrap="square" lIns="0" tIns="0" rIns="0" bIns="0" rtlCol="0" anchor="t"/>
+          <a:lstStyle/>
+          <a:p>
+            <a:pPr indent="0" marL="0">
+              <a:lnSpc>
+                <a:spcPct val="110000"/>
+              </a:lnSpc>
               <a:buNone/>
             </a:pPr>
             <a:r>
@@ -22961,8 +22964,8 @@
         </p:nvSpPr>
         <p:spPr>
           <a:xfrm>
-            <a:off x="1252728" y="2066544"/>
-            <a:ext cx="4572000" cy="713232"/>
+            <a:off x="704088" y="2487168"/>
+            <a:ext cx="5084064" cy="1188720"/>
           </a:xfrm>
           <a:prstGeom prst="rect">
             <a:avLst/>
@@ -22976,12 +22979,12 @@
           <a:p>
             <a:pPr indent="0" marL="0">
               <a:lnSpc>
-                <a:spcPct val="112000"/>
+                <a:spcPct val="120000"/>
               </a:lnSpc>
               <a:buNone/>
             </a:pPr>
             <a:r>
-              <a:rPr lang="en-US" sz="1030" dirty="0">
+              <a:rPr lang="en-US" sz="1050" dirty="0">
                 <a:solidFill>
                   <a:srgbClr val="3A4266"/>
                 </a:solidFill>
@@ -22991,7 +22994,7 @@
               </a:rPr>
               <a:t>Телефон, email, ИНН, СНИЛС, паспорт, банковские карты/счета, ОГРН, IBAN, VIN, дата рождения, IP-адрес, госномер, токены доступа. Для 6 типов — проверка контрольных соотношений: исключает ложные срабатывания на похожих по формату числах.</a:t>
             </a:r>
-            <a:endParaRPr lang="en-US" sz="1030" dirty="0"/>
+            <a:endParaRPr lang="en-US" sz="1050" dirty="0"/>
           </a:p>
         </p:txBody>
       </p:sp>
@@ -23004,11 +23007,11 @@
         <p:spPr>
           <a:xfrm>
             <a:off x="6217920" y="1645920"/>
-            <a:ext cx="5486400" cy="1170432"/>
+            <a:ext cx="5486400" cy="2194560"/>
           </a:xfrm>
           <a:prstGeom prst="roundRect">
             <a:avLst>
-              <a:gd name="adj" fmla="val 6250"/>
+              <a:gd name="adj" fmla="val 3333"/>
             </a:avLst>
           </a:prstGeom>
           <a:solidFill>
@@ -23030,8 +23033,8 @@
         </p:nvSpPr>
         <p:spPr>
           <a:xfrm>
-            <a:off x="6382512" y="1810512"/>
-            <a:ext cx="457200" cy="457200"/>
+            <a:off x="6400800" y="1828800"/>
+            <a:ext cx="438912" cy="438912"/>
           </a:xfrm>
           <a:prstGeom prst="ellipse">
             <a:avLst/>
@@ -23058,8 +23061,8 @@
         </p:blipFill>
         <p:spPr>
           <a:xfrm>
-            <a:off x="6496812" y="1924812"/>
-            <a:ext cx="228600" cy="228600"/>
+            <a:off x="6510528" y="1938528"/>
+            <a:ext cx="219456" cy="219456"/>
           </a:xfrm>
           <a:prstGeom prst="rect">
             <a:avLst/>
@@ -23074,20 +23077,23 @@
         </p:nvSpPr>
         <p:spPr>
           <a:xfrm>
-            <a:off x="6967728" y="1737360"/>
-            <a:ext cx="4572000" cy="347472"/>
-          </a:xfrm>
-          <a:prstGeom prst="rect">
-            <a:avLst/>
-          </a:prstGeom>
-          <a:noFill/>
-          <a:ln/>
-        </p:spPr>
-        <p:txBody>
-          <a:bodyPr wrap="square" lIns="0" tIns="0" rIns="0" bIns="0" rtlCol="0" anchor="ctr"/>
-          <a:lstStyle/>
-          <a:p>
-            <a:pPr indent="0" marL="0">
+            <a:off x="6967728" y="1792224"/>
+            <a:ext cx="4526280" cy="594360"/>
+          </a:xfrm>
+          <a:prstGeom prst="rect">
+            <a:avLst/>
+          </a:prstGeom>
+          <a:noFill/>
+          <a:ln/>
+        </p:spPr>
+        <p:txBody>
+          <a:bodyPr wrap="square" lIns="0" tIns="0" rIns="0" bIns="0" rtlCol="0" anchor="t"/>
+          <a:lstStyle/>
+          <a:p>
+            <a:pPr indent="0" marL="0">
+              <a:lnSpc>
+                <a:spcPct val="110000"/>
+              </a:lnSpc>
               <a:buNone/>
             </a:pPr>
             <a:r>
@@ -23113,8 +23119,8 @@
         </p:nvSpPr>
         <p:spPr>
           <a:xfrm>
-            <a:off x="6967728" y="2066544"/>
-            <a:ext cx="4572000" cy="713232"/>
+            <a:off x="6419088" y="2487168"/>
+            <a:ext cx="5084064" cy="1188720"/>
           </a:xfrm>
           <a:prstGeom prst="rect">
             <a:avLst/>
@@ -23128,12 +23134,12 @@
           <a:p>
             <a:pPr indent="0" marL="0">
               <a:lnSpc>
-                <a:spcPct val="112000"/>
+                <a:spcPct val="120000"/>
               </a:lnSpc>
               <a:buNone/>
             </a:pPr>
             <a:r>
-              <a:rPr lang="en-US" sz="1030" dirty="0">
+              <a:rPr lang="en-US" sz="1050" dirty="0">
                 <a:solidFill>
                   <a:srgbClr val="3A4266"/>
                 </a:solidFill>
@@ -23143,7 +23149,7 @@
               </a:rPr>
               <a:t>Название + regex-паттерн (синтаксис Python re, валидируется при сохранении) + тип токена — закрытый список из 5 значений: PERSON, PROJECT, COMPANY, PRODUCT, CUSTOM. Тестируется прямо на строке паттерна кнопкой «Проверить» — важно вводить реальный пример данных, а не сам regex, иначе система закономерно вернёт «Совпадений не найдено».</a:t>
             </a:r>
-            <a:endParaRPr lang="en-US" sz="1030" dirty="0"/>
+            <a:endParaRPr lang="en-US" sz="1050" dirty="0"/>
           </a:p>
         </p:txBody>
       </p:sp>
@@ -23155,12 +23161,12 @@
         </p:nvSpPr>
         <p:spPr>
           <a:xfrm>
-            <a:off x="502920" y="2999232"/>
-            <a:ext cx="5486400" cy="1170432"/>
+            <a:off x="502920" y="4023360"/>
+            <a:ext cx="5486400" cy="2194560"/>
           </a:xfrm>
           <a:prstGeom prst="roundRect">
             <a:avLst>
-              <a:gd name="adj" fmla="val 6250"/>
+              <a:gd name="adj" fmla="val 3333"/>
             </a:avLst>
           </a:prstGeom>
           <a:solidFill>
@@ -23182,8 +23188,8 @@
         </p:nvSpPr>
         <p:spPr>
           <a:xfrm>
-            <a:off x="667512" y="3163824"/>
-            <a:ext cx="457200" cy="457200"/>
+            <a:off x="685800" y="4206240"/>
+            <a:ext cx="438912" cy="438912"/>
           </a:xfrm>
           <a:prstGeom prst="ellipse">
             <a:avLst/>
@@ -23210,8 +23216,8 @@
         </p:blipFill>
         <p:spPr>
           <a:xfrm>
-            <a:off x="781812" y="3278124"/>
-            <a:ext cx="228600" cy="228600"/>
+            <a:off x="795528" y="4315968"/>
+            <a:ext cx="219456" cy="219456"/>
           </a:xfrm>
           <a:prstGeom prst="rect">
             <a:avLst/>
@@ -23226,20 +23232,23 @@
         </p:nvSpPr>
         <p:spPr>
           <a:xfrm>
-            <a:off x="1252728" y="3090672"/>
-            <a:ext cx="4572000" cy="347472"/>
-          </a:xfrm>
-          <a:prstGeom prst="rect">
-            <a:avLst/>
-          </a:prstGeom>
-          <a:noFill/>
-          <a:ln/>
-        </p:spPr>
-        <p:txBody>
-          <a:bodyPr wrap="square" lIns="0" tIns="0" rIns="0" bIns="0" rtlCol="0" anchor="ctr"/>
-          <a:lstStyle/>
-          <a:p>
-            <a:pPr indent="0" marL="0">
+            <a:off x="1252728" y="4169664"/>
+            <a:ext cx="4526280" cy="594360"/>
+          </a:xfrm>
+          <a:prstGeom prst="rect">
+            <a:avLst/>
+          </a:prstGeom>
+          <a:noFill/>
+          <a:ln/>
+        </p:spPr>
+        <p:txBody>
+          <a:bodyPr wrap="square" lIns="0" tIns="0" rIns="0" bIns="0" rtlCol="0" anchor="t"/>
+          <a:lstStyle/>
+          <a:p>
+            <a:pPr indent="0" marL="0">
+              <a:lnSpc>
+                <a:spcPct val="110000"/>
+              </a:lnSpc>
               <a:buNone/>
             </a:pPr>
             <a:r>
@@ -23265,8 +23274,8 @@
         </p:nvSpPr>
         <p:spPr>
           <a:xfrm>
-            <a:off x="1252728" y="3419856"/>
-            <a:ext cx="4572000" cy="713232"/>
+            <a:off x="704088" y="4864608"/>
+            <a:ext cx="5084064" cy="1188720"/>
           </a:xfrm>
           <a:prstGeom prst="rect">
             <a:avLst/>
@@ -23280,12 +23289,12 @@
           <a:p>
             <a:pPr indent="0" marL="0">
               <a:lnSpc>
-                <a:spcPct val="112000"/>
+                <a:spcPct val="120000"/>
               </a:lnSpc>
               <a:buNone/>
             </a:pPr>
             <a:r>
-              <a:rPr lang="en-US" sz="1030" dirty="0">
+              <a:rPr lang="en-US" sz="1050" dirty="0">
                 <a:solidFill>
                   <a:srgbClr val="3A4266"/>
                 </a:solidFill>
@@ -23295,7 +23304,7 @@
               </a:rPr>
               <a:t>Кодовые названия проектов, внутренние идентификаторы. Точное вхождение в текст запроса, без учёта регистра. Если слово найдено, а смысловая проверка ничего не нашла — запрос всё равно уходит на разбор инспектору.</a:t>
             </a:r>
-            <a:endParaRPr lang="en-US" sz="1030" dirty="0"/>
+            <a:endParaRPr lang="en-US" sz="1050" dirty="0"/>
           </a:p>
         </p:txBody>
       </p:sp>
@@ -23307,12 +23316,12 @@
         </p:nvSpPr>
         <p:spPr>
           <a:xfrm>
-            <a:off x="6217920" y="2999232"/>
-            <a:ext cx="5486400" cy="1170432"/>
+            <a:off x="6217920" y="4023360"/>
+            <a:ext cx="5486400" cy="2194560"/>
           </a:xfrm>
           <a:prstGeom prst="roundRect">
             <a:avLst>
-              <a:gd name="adj" fmla="val 6250"/>
+              <a:gd name="adj" fmla="val 3333"/>
             </a:avLst>
           </a:prstGeom>
           <a:solidFill>
@@ -23334,8 +23343,8 @@
         </p:nvSpPr>
         <p:spPr>
           <a:xfrm>
-            <a:off x="6382512" y="3163824"/>
-            <a:ext cx="457200" cy="457200"/>
+            <a:off x="6400800" y="4206240"/>
+            <a:ext cx="438912" cy="438912"/>
           </a:xfrm>
           <a:prstGeom prst="ellipse">
             <a:avLst/>
@@ -23362,8 +23371,8 @@
         </p:blipFill>
         <p:spPr>
           <a:xfrm>
-            <a:off x="6496812" y="3278124"/>
-            <a:ext cx="228600" cy="228600"/>
+            <a:off x="6510528" y="4315968"/>
+            <a:ext cx="219456" cy="219456"/>
           </a:xfrm>
           <a:prstGeom prst="rect">
             <a:avLst/>
@@ -23378,20 +23387,23 @@
         </p:nvSpPr>
         <p:spPr>
           <a:xfrm>
-            <a:off x="6967728" y="3090672"/>
-            <a:ext cx="4572000" cy="347472"/>
-          </a:xfrm>
-          <a:prstGeom prst="rect">
-            <a:avLst/>
-          </a:prstGeom>
-          <a:noFill/>
-          <a:ln/>
-        </p:spPr>
-        <p:txBody>
-          <a:bodyPr wrap="square" lIns="0" tIns="0" rIns="0" bIns="0" rtlCol="0" anchor="ctr"/>
-          <a:lstStyle/>
-          <a:p>
-            <a:pPr indent="0" marL="0">
+            <a:off x="6967728" y="4169664"/>
+            <a:ext cx="4526280" cy="594360"/>
+          </a:xfrm>
+          <a:prstGeom prst="rect">
+            <a:avLst/>
+          </a:prstGeom>
+          <a:noFill/>
+          <a:ln/>
+        </p:spPr>
+        <p:txBody>
+          <a:bodyPr wrap="square" lIns="0" tIns="0" rIns="0" bIns="0" rtlCol="0" anchor="t"/>
+          <a:lstStyle/>
+          <a:p>
+            <a:pPr indent="0" marL="0">
+              <a:lnSpc>
+                <a:spcPct val="110000"/>
+              </a:lnSpc>
               <a:buNone/>
             </a:pPr>
             <a:r>
@@ -23417,8 +23429,8 @@
         </p:nvSpPr>
         <p:spPr>
           <a:xfrm>
-            <a:off x="6967728" y="3419856"/>
-            <a:ext cx="4572000" cy="713232"/>
+            <a:off x="6419088" y="4864608"/>
+            <a:ext cx="5084064" cy="1188720"/>
           </a:xfrm>
           <a:prstGeom prst="rect">
             <a:avLst/>
@@ -23432,12 +23444,12 @@
           <a:p>
             <a:pPr indent="0" marL="0">
               <a:lnSpc>
-                <a:spcPct val="112000"/>
+                <a:spcPct val="120000"/>
               </a:lnSpc>
               <a:buNone/>
             </a:pPr>
             <a:r>
-              <a:rPr lang="en-US" sz="1030" dirty="0">
+              <a:rPr lang="en-US" sz="1050" dirty="0">
                 <a:solidFill>
                   <a:srgbClr val="3A4266"/>
                 </a:solidFill>
@@ -23447,7 +23459,7 @@
               </a:rPr>
               <a:t>Список наименований, которые всегда скрываются модулем обезличивания. На решение «Пропустить / На проверку / Заблокировать» не влияет: запрос идёт дальше, но перечисленные слова в нём уже скрыты.</a:t>
             </a:r>
-            <a:endParaRPr lang="en-US" sz="1030" dirty="0"/>
+            <a:endParaRPr lang="en-US" sz="1050" dirty="0"/>
           </a:p>
         </p:txBody>
       </p:sp>

</xml_diff>